<commit_message>
Update project with latest local version
</commit_message>
<xml_diff>
--- a/backend/generated_files/slides.pptx
+++ b/backend/generated_files/slides.pptx
@@ -8,10 +8,6 @@
     <p:sldId id="256" r:id="rId7"/>
     <p:sldId id="257" r:id="rId8"/>
     <p:sldId id="258" r:id="rId9"/>
-    <p:sldId id="259" r:id="rId10"/>
-    <p:sldId id="260" r:id="rId11"/>
-    <p:sldId id="261" r:id="rId12"/>
-    <p:sldId id="262" r:id="rId13"/>
   </p:sldIdLst>
   <p:sldSz cx="9144000" cy="6858000" type="screen4x3"/>
   <p:notesSz cx="6858000" cy="9144000"/>
@@ -3110,7 +3106,13 @@
           <a:lstStyle/>
           <a:p>
             <a:r>
-              <a:t>Web Application Security Analyzer Comprehensive Report</a:t>
+              <a:rPr>
+                <a:solidFill>
+                  <a:srgbClr val="000000"/>
+                </a:solidFill>
+                <a:latin typeface="Times New Roman"/>
+              </a:rPr>
+              <a:t>ASTHRA Project Documentation</a:t>
             </a:r>
           </a:p>
         </p:txBody>
@@ -3130,11 +3132,14 @@
           <a:bodyPr/>
           <a:lstStyle/>
           <a:p>
-            <a:pPr>
-              <a:defRPr sz="1800"/>
-            </a:pPr>
-            <a:r>
-              <a:t>The Web Application Security Analyzer is an automated tool designed to identify vulnerabilities in web applications through dynamic scanning and risk assessment. It provides detailed reports on security flaws, prioritization, and remediation guidance. The analyzer integrates with CI/CD pipelines for continuous monitoring and compliance adherence.</a:t>
+            <a:r>
+              <a:rPr>
+                <a:solidFill>
+                  <a:srgbClr val="000000"/>
+                </a:solidFill>
+                <a:latin typeface="Times New Roman"/>
+              </a:rPr>
+              <a:t>Generated documentation for: how are you</a:t>
             </a:r>
           </a:p>
         </p:txBody>
@@ -3173,6 +3178,12 @@
           <a:lstStyle/>
           <a:p>
             <a:r>
+              <a:rPr>
+                <a:solidFill>
+                  <a:srgbClr val="000000"/>
+                </a:solidFill>
+                <a:latin typeface="Times New Roman"/>
+              </a:rPr>
               <a:t>Overview</a:t>
             </a:r>
           </a:p>
@@ -3194,21 +3205,78 @@
           <a:lstStyle/>
           <a:p/>
           <a:p>
-            <a:pPr/>
-            <a:r>
-              <a:t>Automated security assessment for web applications</a:t>
-            </a:r>
-          </a:p>
-          <a:p>
-            <a:pPr/>
-            <a:r>
-              <a:t>Targeted at RESTful APIs, web forms, and authentication flows</a:t>
-            </a:r>
-          </a:p>
-          <a:p>
-            <a:pPr/>
-            <a:r>
-              <a:t>Covers OWASP Top 10 vulnerabilities and custom rule sets</a:t>
+            <a:pPr>
+              <a:defRPr sz="1800">
+                <a:solidFill>
+                  <a:srgbClr val="000000"/>
+                </a:solidFill>
+                <a:latin typeface="Times New Roman"/>
+              </a:defRPr>
+            </a:pPr>
+            <a:r>
+              <a:t>Project statement received and logged.</a:t>
+            </a:r>
+          </a:p>
+          <a:p>
+            <a:pPr>
+              <a:defRPr sz="1800">
+                <a:solidFill>
+                  <a:srgbClr val="000000"/>
+                </a:solidFill>
+                <a:latin typeface="Times New Roman"/>
+              </a:defRPr>
+            </a:pPr>
+            <a:r>
+              <a:t>ASTHRA generated offline demo content.</a:t>
+            </a:r>
+          </a:p>
+          <a:p>
+            <a:pPr>
+              <a:defRPr sz="1800">
+                <a:solidFill>
+                  <a:srgbClr val="000000"/>
+                </a:solidFill>
+                <a:latin typeface="Times New Roman"/>
+              </a:defRPr>
+            </a:pPr>
+            <a:r>
+              <a:t>No upload provided.</a:t>
+            </a:r>
+          </a:p>
+        </p:txBody>
+      </p:sp>
+      <p:sp>
+        <p:nvSpPr>
+          <p:cNvPr id="4" name="TextBox 3"/>
+          <p:cNvSpPr txBox="1"/>
+          <p:nvPr/>
+        </p:nvSpPr>
+        <p:spPr>
+          <a:xfrm>
+            <a:off x="7772400" y="6400800"/>
+            <a:ext cx="914400" cy="457200"/>
+          </a:xfrm>
+          <a:prstGeom prst="rect">
+            <a:avLst/>
+          </a:prstGeom>
+          <a:noFill/>
+        </p:spPr>
+        <p:txBody>
+          <a:bodyPr wrap="none">
+            <a:spAutoFit/>
+          </a:bodyPr>
+          <a:lstStyle/>
+          <a:p>
+            <a:pPr>
+              <a:defRPr sz="1200">
+                <a:solidFill>
+                  <a:srgbClr val="646464"/>
+                </a:solidFill>
+                <a:latin typeface="Times New Roman"/>
+              </a:defRPr>
+            </a:pPr>
+            <a:r>
+              <a:t>2</a:t>
             </a:r>
           </a:p>
         </p:txBody>
@@ -3247,7 +3315,13 @@
           <a:lstStyle/>
           <a:p>
             <a:r>
-              <a:t>Key Features</a:t>
+              <a:rPr>
+                <a:solidFill>
+                  <a:srgbClr val="000000"/>
+                </a:solidFill>
+                <a:latin typeface="Times New Roman"/>
+              </a:rPr>
+              <a:t>Patent-style Claims</a:t>
             </a:r>
           </a:p>
         </p:txBody>
@@ -3268,323 +3342,52 @@
           <a:lstStyle/>
           <a:p/>
           <a:p>
-            <a:pPr/>
-            <a:r>
-              <a:t>Real-time vulnerability scanning with configurable depth levels</a:t>
-            </a:r>
-          </a:p>
-          <a:p>
-            <a:pPr/>
-            <a:r>
-              <a:t>Extensible vulnerability database with CVE mapping</a:t>
-            </a:r>
-          </a:p>
-          <a:p>
-            <a:pPr/>
-            <a:r>
-              <a:t>Risk scoring algorithm based on impact, exploit likelihood, and remediation complexity</a:t>
-            </a:r>
-          </a:p>
-        </p:txBody>
-      </p:sp>
-    </p:spTree>
-  </p:cSld>
-  <p:clrMapOvr>
-    <a:masterClrMapping/>
-  </p:clrMapOvr>
-</p:sld>
-</file>
-
-<file path=ppt/slides/slide4.xml><?xml version="1.0" encoding="utf-8"?>
-<p:sld xmlns:a="http://schemas.openxmlformats.org/drawingml/2006/main" xmlns:p="http://schemas.openxmlformats.org/presentationml/2006/main" xmlns:r="http://schemas.openxmlformats.org/officeDocument/2006/relationships">
-  <p:cSld>
-    <p:spTree>
-      <p:nvGrpSpPr>
-        <p:cNvPr id="1" name=""/>
-        <p:cNvGrpSpPr/>
-        <p:nvPr/>
-      </p:nvGrpSpPr>
-      <p:grpSpPr/>
-      <p:sp>
-        <p:nvSpPr>
-          <p:cNvPr id="2" name="Title 1"/>
-          <p:cNvSpPr>
-            <a:spLocks noGrp="1"/>
-          </p:cNvSpPr>
-          <p:nvPr>
-            <p:ph type="title"/>
-          </p:nvPr>
-        </p:nvSpPr>
-        <p:spPr/>
-        <p:txBody>
-          <a:bodyPr/>
-          <a:lstStyle/>
-          <a:p>
-            <a:r>
-              <a:t>Scanning Methodology</a:t>
-            </a:r>
-          </a:p>
-        </p:txBody>
-      </p:sp>
-      <p:sp>
-        <p:nvSpPr>
-          <p:cNvPr id="3" name="Content Placeholder 2"/>
-          <p:cNvSpPr>
-            <a:spLocks noGrp="1"/>
-          </p:cNvSpPr>
-          <p:nvPr>
-            <p:ph idx="1"/>
-          </p:nvPr>
-        </p:nvSpPr>
-        <p:spPr/>
-        <p:txBody>
-          <a:bodyPr/>
-          <a:lstStyle/>
-          <a:p/>
-          <a:p>
-            <a:pPr/>
-            <a:r>
-              <a:t>Differential analysis of application responses to detect anomalies</a:t>
-            </a:r>
-          </a:p>
-          <a:p>
-            <a:pPr/>
-            <a:r>
-              <a:t>Automated payload injection and fuzzing for input validation testing</a:t>
-            </a:r>
-          </a:p>
-          <a:p>
-            <a:pPr/>
-            <a:r>
-              <a:t>Session management and authentication bypass detection</a:t>
-            </a:r>
-          </a:p>
-        </p:txBody>
-      </p:sp>
-    </p:spTree>
-  </p:cSld>
-  <p:clrMapOvr>
-    <a:masterClrMapping/>
-  </p:clrMapOvr>
-</p:sld>
-</file>
-
-<file path=ppt/slides/slide5.xml><?xml version="1.0" encoding="utf-8"?>
-<p:sld xmlns:a="http://schemas.openxmlformats.org/drawingml/2006/main" xmlns:p="http://schemas.openxmlformats.org/presentationml/2006/main" xmlns:r="http://schemas.openxmlformats.org/officeDocument/2006/relationships">
-  <p:cSld>
-    <p:spTree>
-      <p:nvGrpSpPr>
-        <p:cNvPr id="1" name=""/>
-        <p:cNvGrpSpPr/>
-        <p:nvPr/>
-      </p:nvGrpSpPr>
-      <p:grpSpPr/>
-      <p:sp>
-        <p:nvSpPr>
-          <p:cNvPr id="2" name="Title 1"/>
-          <p:cNvSpPr>
-            <a:spLocks noGrp="1"/>
-          </p:cNvSpPr>
-          <p:nvPr>
-            <p:ph type="title"/>
-          </p:nvPr>
-        </p:nvSpPr>
-        <p:spPr/>
-        <p:txBody>
-          <a:bodyPr/>
-          <a:lstStyle/>
-          <a:p>
-            <a:r>
-              <a:t>Reporting &amp; Analytics</a:t>
-            </a:r>
-          </a:p>
-        </p:txBody>
-      </p:sp>
-      <p:sp>
-        <p:nvSpPr>
-          <p:cNvPr id="3" name="Content Placeholder 2"/>
-          <p:cNvSpPr>
-            <a:spLocks noGrp="1"/>
-          </p:cNvSpPr>
-          <p:nvPr>
-            <p:ph idx="1"/>
-          </p:nvPr>
-        </p:nvSpPr>
-        <p:spPr/>
-        <p:txBody>
-          <a:bodyPr/>
-          <a:lstStyle/>
-          <a:p/>
-          <a:p>
-            <a:pPr/>
-            <a:r>
-              <a:t>Interactive dashboards with severity distribution and trend analysis</a:t>
-            </a:r>
-          </a:p>
-          <a:p>
-            <a:pPr/>
-            <a:r>
-              <a:t>Exportable reports in PDF, CSV, and JSON formats</a:t>
-            </a:r>
-          </a:p>
-          <a:p>
-            <a:pPr/>
-            <a:r>
-              <a:t>Historical data tracking for vulnerability recurrence analysis</a:t>
-            </a:r>
-          </a:p>
-        </p:txBody>
-      </p:sp>
-    </p:spTree>
-  </p:cSld>
-  <p:clrMapOvr>
-    <a:masterClrMapping/>
-  </p:clrMapOvr>
-</p:sld>
-</file>
-
-<file path=ppt/slides/slide6.xml><?xml version="1.0" encoding="utf-8"?>
-<p:sld xmlns:a="http://schemas.openxmlformats.org/drawingml/2006/main" xmlns:p="http://schemas.openxmlformats.org/presentationml/2006/main" xmlns:r="http://schemas.openxmlformats.org/officeDocument/2006/relationships">
-  <p:cSld>
-    <p:spTree>
-      <p:nvGrpSpPr>
-        <p:cNvPr id="1" name=""/>
-        <p:cNvGrpSpPr/>
-        <p:nvPr/>
-      </p:nvGrpSpPr>
-      <p:grpSpPr/>
-      <p:sp>
-        <p:nvSpPr>
-          <p:cNvPr id="2" name="Title 1"/>
-          <p:cNvSpPr>
-            <a:spLocks noGrp="1"/>
-          </p:cNvSpPr>
-          <p:nvPr>
-            <p:ph type="title"/>
-          </p:nvPr>
-        </p:nvSpPr>
-        <p:spPr/>
-        <p:txBody>
-          <a:bodyPr/>
-          <a:lstStyle/>
-          <a:p>
-            <a:r>
-              <a:t>Integration &amp; Deployment</a:t>
-            </a:r>
-          </a:p>
-        </p:txBody>
-      </p:sp>
-      <p:sp>
-        <p:nvSpPr>
-          <p:cNvPr id="3" name="Content Placeholder 2"/>
-          <p:cNvSpPr>
-            <a:spLocks noGrp="1"/>
-          </p:cNvSpPr>
-          <p:nvPr>
-            <p:ph idx="1"/>
-          </p:nvPr>
-        </p:nvSpPr>
-        <p:spPr/>
-        <p:txBody>
-          <a:bodyPr/>
-          <a:lstStyle/>
-          <a:p/>
-          <a:p>
-            <a:pPr/>
-            <a:r>
-              <a:t>CI/CD pipeline integration via CLI and REST API</a:t>
-            </a:r>
-          </a:p>
-          <a:p>
-            <a:pPr/>
-            <a:r>
-              <a:t>Containerized deployment for Kubernetes and Docker environments</a:t>
-            </a:r>
-          </a:p>
-          <a:p>
-            <a:pPr/>
-            <a:r>
-              <a:t>Support for SaaS platforms and on-premises installations</a:t>
-            </a:r>
-          </a:p>
-        </p:txBody>
-      </p:sp>
-    </p:spTree>
-  </p:cSld>
-  <p:clrMapOvr>
-    <a:masterClrMapping/>
-  </p:clrMapOvr>
-</p:sld>
-</file>
-
-<file path=ppt/slides/slide7.xml><?xml version="1.0" encoding="utf-8"?>
-<p:sld xmlns:a="http://schemas.openxmlformats.org/drawingml/2006/main" xmlns:p="http://schemas.openxmlformats.org/presentationml/2006/main" xmlns:r="http://schemas.openxmlformats.org/officeDocument/2006/relationships">
-  <p:cSld>
-    <p:spTree>
-      <p:nvGrpSpPr>
-        <p:cNvPr id="1" name=""/>
-        <p:cNvGrpSpPr/>
-        <p:nvPr/>
-      </p:nvGrpSpPr>
-      <p:grpSpPr/>
-      <p:sp>
-        <p:nvSpPr>
-          <p:cNvPr id="2" name="Title 1"/>
-          <p:cNvSpPr>
-            <a:spLocks noGrp="1"/>
-          </p:cNvSpPr>
-          <p:nvPr>
-            <p:ph type="title"/>
-          </p:nvPr>
-        </p:nvSpPr>
-        <p:spPr/>
-        <p:txBody>
-          <a:bodyPr/>
-          <a:lstStyle/>
-          <a:p>
-            <a:r>
-              <a:t>Patent-style Claims</a:t>
-            </a:r>
-          </a:p>
-        </p:txBody>
-      </p:sp>
-      <p:sp>
-        <p:nvSpPr>
-          <p:cNvPr id="3" name="Content Placeholder 2"/>
-          <p:cNvSpPr>
-            <a:spLocks noGrp="1"/>
-          </p:cNvSpPr>
-          <p:nvPr>
-            <p:ph idx="1"/>
-          </p:nvPr>
-        </p:nvSpPr>
-        <p:spPr/>
-        <p:txBody>
-          <a:bodyPr/>
-          <a:lstStyle/>
-          <a:p/>
-          <a:p>
-            <a:pPr/>
-            <a:r>
-              <a:t>A system that automates dynamic security scanning of web applications through configurable test vectors and payload injection sequences</a:t>
-            </a:r>
-          </a:p>
-          <a:p>
-            <a:pPr/>
-            <a:r>
-              <a:t>A method for prioritizing detected vulnerabilities using a weighted risk score algorithm incorporating exploit likelihood and business impact metrics</a:t>
-            </a:r>
-          </a:p>
-          <a:p>
-            <a:pPr/>
-            <a:r>
-              <a:t>An integrated reporting module generating compliance-ready documentation with remediation pathways and CVE cross-references</a:t>
-            </a:r>
-          </a:p>
-          <a:p>
-            <a:pPr/>
-            <a:r>
-              <a:t>A deployment framework enabling seamless integration with continuous integration/continuous deployment pipelines through standardized API endpoints</a:t>
+            <a:pPr>
+              <a:defRPr sz="1600">
+                <a:solidFill>
+                  <a:srgbClr val="000000"/>
+                </a:solidFill>
+                <a:latin typeface="Times New Roman"/>
+              </a:defRPr>
+            </a:pPr>
+            <a:r>
+              <a:t>Automated generation demo.</a:t>
+            </a:r>
+          </a:p>
+        </p:txBody>
+      </p:sp>
+      <p:sp>
+        <p:nvSpPr>
+          <p:cNvPr id="4" name="TextBox 3"/>
+          <p:cNvSpPr txBox="1"/>
+          <p:nvPr/>
+        </p:nvSpPr>
+        <p:spPr>
+          <a:xfrm>
+            <a:off x="7772400" y="6400800"/>
+            <a:ext cx="914400" cy="457200"/>
+          </a:xfrm>
+          <a:prstGeom prst="rect">
+            <a:avLst/>
+          </a:prstGeom>
+          <a:noFill/>
+        </p:spPr>
+        <p:txBody>
+          <a:bodyPr wrap="none">
+            <a:spAutoFit/>
+          </a:bodyPr>
+          <a:lstStyle/>
+          <a:p>
+            <a:pPr>
+              <a:defRPr sz="1200">
+                <a:solidFill>
+                  <a:srgbClr val="646464"/>
+                </a:solidFill>
+                <a:latin typeface="Times New Roman"/>
+              </a:defRPr>
+            </a:pPr>
+            <a:r>
+              <a:t>3</a:t>
             </a:r>
           </a:p>
         </p:txBody>

</xml_diff>

<commit_message>
Fix AttributeError in _normalize_plan and update generated files
</commit_message>
<xml_diff>
--- a/backend/generated_files/slides.pptx
+++ b/backend/generated_files/slides.pptx
@@ -8,6 +8,11 @@
     <p:sldId id="256" r:id="rId7"/>
     <p:sldId id="257" r:id="rId8"/>
     <p:sldId id="258" r:id="rId9"/>
+    <p:sldId id="259" r:id="rId10"/>
+    <p:sldId id="260" r:id="rId11"/>
+    <p:sldId id="261" r:id="rId12"/>
+    <p:sldId id="262" r:id="rId13"/>
+    <p:sldId id="263" r:id="rId14"/>
   </p:sldIdLst>
   <p:sldSz cx="9144000" cy="6858000" type="screen4x3"/>
   <p:notesSz cx="6858000" cy="9144000"/>
@@ -3112,7 +3117,7 @@
                 </a:solidFill>
                 <a:latin typeface="Times New Roman"/>
               </a:rPr>
-              <a:t>ASTHRA Project Documentation</a:t>
+              <a:t>Technical Assessment Report: code_crush</a:t>
             </a:r>
           </a:p>
         </p:txBody>
@@ -3139,7 +3144,7 @@
                 </a:solidFill>
                 <a:latin typeface="Times New Roman"/>
               </a:rPr>
-              <a:t>Generated documentation for: how are you</a:t>
+              <a:t>The GitHub repository 'code_crush' hosted by user Midhun-M-git contains a comprehensive collection of coding challenges and solutions, with a focus on algorithmic problem-solving and data structures. The project is organized into multiple directories, each representing a different category of coding problems, such as arrays, strings, linked lists, trees, and graphs. Solutions are provided in both Python and Java, demonstrating the versatility and applicability of the code across different programming languages. The repository includes detailed explanations for each solution, enhancing its educational value. Overall, code_crush serves as an excellent resource for developers and students looking to improve their coding skills through practical examples and well-documented solutions. (Analyzed GitHub Repo: https://github.com/Midhun-M-git/code_crush)</a:t>
             </a:r>
           </a:p>
         </p:txBody>
@@ -3184,7 +3189,7 @@
                 </a:solidFill>
                 <a:latin typeface="Times New Roman"/>
               </a:rPr>
-              <a:t>Overview</a:t>
+              <a:t>Introduction</a:t>
             </a:r>
           </a:p>
         </p:txBody>
@@ -3214,7 +3219,7 @@
               </a:defRPr>
             </a:pPr>
             <a:r>
-              <a:t>Project statement received and logged.</a:t>
+              <a:t>The code_crush repository is a curated collection of coding challenges and their corresponding solutions, designed to help developers and students enhance their algorithmic and data structure skills.</a:t>
             </a:r>
           </a:p>
           <a:p>
@@ -3227,20 +3232,7 @@
               </a:defRPr>
             </a:pPr>
             <a:r>
-              <a:t>ASTHRA generated offline demo content.</a:t>
-            </a:r>
-          </a:p>
-          <a:p>
-            <a:pPr>
-              <a:defRPr sz="1800">
-                <a:solidFill>
-                  <a:srgbClr val="000000"/>
-                </a:solidFill>
-                <a:latin typeface="Times New Roman"/>
-              </a:defRPr>
-            </a:pPr>
-            <a:r>
-              <a:t>No upload provided.</a:t>
+              <a:t>The repository is hosted on GitHub and managed by the user Midhun-M-git.</a:t>
             </a:r>
           </a:p>
         </p:txBody>
@@ -3321,7 +3313,7 @@
                 </a:solidFill>
                 <a:latin typeface="Times New Roman"/>
               </a:rPr>
-              <a:t>Patent-style Claims</a:t>
+              <a:t>Project Structure</a:t>
             </a:r>
           </a:p>
         </p:txBody>
@@ -3343,7 +3335,7 @@
           <a:p/>
           <a:p>
             <a:pPr>
-              <a:defRPr sz="1600">
+              <a:defRPr sz="1800">
                 <a:solidFill>
                   <a:srgbClr val="000000"/>
                 </a:solidFill>
@@ -3351,7 +3343,20 @@
               </a:defRPr>
             </a:pPr>
             <a:r>
-              <a:t>Automated generation demo.</a:t>
+              <a:t>The project is organized into multiple directories, each representing a different category of coding problems, such as arrays, strings, linked lists, trees, and graphs.</a:t>
+            </a:r>
+          </a:p>
+          <a:p>
+            <a:pPr>
+              <a:defRPr sz="1800">
+                <a:solidFill>
+                  <a:srgbClr val="000000"/>
+                </a:solidFill>
+                <a:latin typeface="Times New Roman"/>
+              </a:defRPr>
+            </a:pPr>
+            <a:r>
+              <a:t>Each directory contains a series of problem files, with solutions provided in both Python and Java.</a:t>
             </a:r>
           </a:p>
         </p:txBody>
@@ -3388,6 +3393,626 @@
             </a:pPr>
             <a:r>
               <a:t>3</a:t>
+            </a:r>
+          </a:p>
+        </p:txBody>
+      </p:sp>
+    </p:spTree>
+  </p:cSld>
+  <p:clrMapOvr>
+    <a:masterClrMapping/>
+  </p:clrMapOvr>
+</p:sld>
+</file>
+
+<file path=ppt/slides/slide4.xml><?xml version="1.0" encoding="utf-8"?>
+<p:sld xmlns:a="http://schemas.openxmlformats.org/drawingml/2006/main" xmlns:p="http://schemas.openxmlformats.org/presentationml/2006/main" xmlns:r="http://schemas.openxmlformats.org/officeDocument/2006/relationships">
+  <p:cSld>
+    <p:spTree>
+      <p:nvGrpSpPr>
+        <p:cNvPr id="1" name=""/>
+        <p:cNvGrpSpPr/>
+        <p:nvPr/>
+      </p:nvGrpSpPr>
+      <p:grpSpPr/>
+      <p:sp>
+        <p:nvSpPr>
+          <p:cNvPr id="2" name="Title 1"/>
+          <p:cNvSpPr>
+            <a:spLocks noGrp="1"/>
+          </p:cNvSpPr>
+          <p:nvPr>
+            <p:ph type="title"/>
+          </p:nvPr>
+        </p:nvSpPr>
+        <p:spPr/>
+        <p:txBody>
+          <a:bodyPr/>
+          <a:lstStyle/>
+          <a:p>
+            <a:r>
+              <a:rPr>
+                <a:solidFill>
+                  <a:srgbClr val="000000"/>
+                </a:solidFill>
+                <a:latin typeface="Times New Roman"/>
+              </a:rPr>
+              <a:t>Content Overview</a:t>
+            </a:r>
+          </a:p>
+        </p:txBody>
+      </p:sp>
+      <p:sp>
+        <p:nvSpPr>
+          <p:cNvPr id="3" name="Content Placeholder 2"/>
+          <p:cNvSpPr>
+            <a:spLocks noGrp="1"/>
+          </p:cNvSpPr>
+          <p:nvPr>
+            <p:ph idx="1"/>
+          </p:nvPr>
+        </p:nvSpPr>
+        <p:spPr/>
+        <p:txBody>
+          <a:bodyPr/>
+          <a:lstStyle/>
+          <a:p/>
+          <a:p>
+            <a:pPr>
+              <a:defRPr sz="1800">
+                <a:solidFill>
+                  <a:srgbClr val="000000"/>
+                </a:solidFill>
+                <a:latin typeface="Times New Roman"/>
+              </a:defRPr>
+            </a:pPr>
+            <a:r>
+              <a:t>The repository includes a wide range of coding challenges, covering fundamental data structures and advanced algorithmic concepts.</a:t>
+            </a:r>
+          </a:p>
+          <a:p>
+            <a:pPr>
+              <a:defRPr sz="1800">
+                <a:solidFill>
+                  <a:srgbClr val="000000"/>
+                </a:solidFill>
+                <a:latin typeface="Times New Roman"/>
+              </a:defRPr>
+            </a:pPr>
+            <a:r>
+              <a:t>Solutions are provided in both Python and Java, catering to developers familiar with these programming languages.</a:t>
+            </a:r>
+          </a:p>
+        </p:txBody>
+      </p:sp>
+      <p:sp>
+        <p:nvSpPr>
+          <p:cNvPr id="4" name="TextBox 3"/>
+          <p:cNvSpPr txBox="1"/>
+          <p:nvPr/>
+        </p:nvSpPr>
+        <p:spPr>
+          <a:xfrm>
+            <a:off x="7772400" y="6400800"/>
+            <a:ext cx="914400" cy="457200"/>
+          </a:xfrm>
+          <a:prstGeom prst="rect">
+            <a:avLst/>
+          </a:prstGeom>
+          <a:noFill/>
+        </p:spPr>
+        <p:txBody>
+          <a:bodyPr wrap="none">
+            <a:spAutoFit/>
+          </a:bodyPr>
+          <a:lstStyle/>
+          <a:p>
+            <a:pPr>
+              <a:defRPr sz="1200">
+                <a:solidFill>
+                  <a:srgbClr val="646464"/>
+                </a:solidFill>
+                <a:latin typeface="Times New Roman"/>
+              </a:defRPr>
+            </a:pPr>
+            <a:r>
+              <a:t>4</a:t>
+            </a:r>
+          </a:p>
+        </p:txBody>
+      </p:sp>
+    </p:spTree>
+  </p:cSld>
+  <p:clrMapOvr>
+    <a:masterClrMapping/>
+  </p:clrMapOvr>
+</p:sld>
+</file>
+
+<file path=ppt/slides/slide5.xml><?xml version="1.0" encoding="utf-8"?>
+<p:sld xmlns:a="http://schemas.openxmlformats.org/drawingml/2006/main" xmlns:p="http://schemas.openxmlformats.org/presentationml/2006/main" xmlns:r="http://schemas.openxmlformats.org/officeDocument/2006/relationships">
+  <p:cSld>
+    <p:spTree>
+      <p:nvGrpSpPr>
+        <p:cNvPr id="1" name=""/>
+        <p:cNvGrpSpPr/>
+        <p:nvPr/>
+      </p:nvGrpSpPr>
+      <p:grpSpPr/>
+      <p:sp>
+        <p:nvSpPr>
+          <p:cNvPr id="2" name="Title 1"/>
+          <p:cNvSpPr>
+            <a:spLocks noGrp="1"/>
+          </p:cNvSpPr>
+          <p:nvPr>
+            <p:ph type="title"/>
+          </p:nvPr>
+        </p:nvSpPr>
+        <p:spPr/>
+        <p:txBody>
+          <a:bodyPr/>
+          <a:lstStyle/>
+          <a:p>
+            <a:r>
+              <a:rPr>
+                <a:solidFill>
+                  <a:srgbClr val="000000"/>
+                </a:solidFill>
+                <a:latin typeface="Times New Roman"/>
+              </a:rPr>
+              <a:t>Educational Value</a:t>
+            </a:r>
+          </a:p>
+        </p:txBody>
+      </p:sp>
+      <p:sp>
+        <p:nvSpPr>
+          <p:cNvPr id="3" name="Content Placeholder 2"/>
+          <p:cNvSpPr>
+            <a:spLocks noGrp="1"/>
+          </p:cNvSpPr>
+          <p:nvPr>
+            <p:ph idx="1"/>
+          </p:nvPr>
+        </p:nvSpPr>
+        <p:spPr/>
+        <p:txBody>
+          <a:bodyPr/>
+          <a:lstStyle/>
+          <a:p/>
+          <a:p>
+            <a:pPr>
+              <a:defRPr sz="1800">
+                <a:solidFill>
+                  <a:srgbClr val="000000"/>
+                </a:solidFill>
+                <a:latin typeface="Times New Roman"/>
+              </a:defRPr>
+            </a:pPr>
+            <a:r>
+              <a:t>Each solution is accompanied by detailed explanations, making the repository an excellent learning tool for developers and students.</a:t>
+            </a:r>
+          </a:p>
+          <a:p>
+            <a:pPr>
+              <a:defRPr sz="1800">
+                <a:solidFill>
+                  <a:srgbClr val="000000"/>
+                </a:solidFill>
+                <a:latin typeface="Times New Roman"/>
+              </a:defRPr>
+            </a:pPr>
+            <a:r>
+              <a:t>The variety of problems and solutions helps users to practice and reinforce their understanding of coding concepts.</a:t>
+            </a:r>
+          </a:p>
+        </p:txBody>
+      </p:sp>
+      <p:sp>
+        <p:nvSpPr>
+          <p:cNvPr id="4" name="TextBox 3"/>
+          <p:cNvSpPr txBox="1"/>
+          <p:nvPr/>
+        </p:nvSpPr>
+        <p:spPr>
+          <a:xfrm>
+            <a:off x="7772400" y="6400800"/>
+            <a:ext cx="914400" cy="457200"/>
+          </a:xfrm>
+          <a:prstGeom prst="rect">
+            <a:avLst/>
+          </a:prstGeom>
+          <a:noFill/>
+        </p:spPr>
+        <p:txBody>
+          <a:bodyPr wrap="none">
+            <a:spAutoFit/>
+          </a:bodyPr>
+          <a:lstStyle/>
+          <a:p>
+            <a:pPr>
+              <a:defRPr sz="1200">
+                <a:solidFill>
+                  <a:srgbClr val="646464"/>
+                </a:solidFill>
+                <a:latin typeface="Times New Roman"/>
+              </a:defRPr>
+            </a:pPr>
+            <a:r>
+              <a:t>5</a:t>
+            </a:r>
+          </a:p>
+        </p:txBody>
+      </p:sp>
+    </p:spTree>
+  </p:cSld>
+  <p:clrMapOvr>
+    <a:masterClrMapping/>
+  </p:clrMapOvr>
+</p:sld>
+</file>
+
+<file path=ppt/slides/slide6.xml><?xml version="1.0" encoding="utf-8"?>
+<p:sld xmlns:a="http://schemas.openxmlformats.org/drawingml/2006/main" xmlns:p="http://schemas.openxmlformats.org/presentationml/2006/main" xmlns:r="http://schemas.openxmlformats.org/officeDocument/2006/relationships">
+  <p:cSld>
+    <p:spTree>
+      <p:nvGrpSpPr>
+        <p:cNvPr id="1" name=""/>
+        <p:cNvGrpSpPr/>
+        <p:nvPr/>
+      </p:nvGrpSpPr>
+      <p:grpSpPr/>
+      <p:sp>
+        <p:nvSpPr>
+          <p:cNvPr id="2" name="Title 1"/>
+          <p:cNvSpPr>
+            <a:spLocks noGrp="1"/>
+          </p:cNvSpPr>
+          <p:nvPr>
+            <p:ph type="title"/>
+          </p:nvPr>
+        </p:nvSpPr>
+        <p:spPr/>
+        <p:txBody>
+          <a:bodyPr/>
+          <a:lstStyle/>
+          <a:p>
+            <a:r>
+              <a:rPr>
+                <a:solidFill>
+                  <a:srgbClr val="000000"/>
+                </a:solidFill>
+                <a:latin typeface="Times New Roman"/>
+              </a:rPr>
+              <a:t>Technical Excellence</a:t>
+            </a:r>
+          </a:p>
+        </p:txBody>
+      </p:sp>
+      <p:sp>
+        <p:nvSpPr>
+          <p:cNvPr id="3" name="Content Placeholder 2"/>
+          <p:cNvSpPr>
+            <a:spLocks noGrp="1"/>
+          </p:cNvSpPr>
+          <p:nvPr>
+            <p:ph idx="1"/>
+          </p:nvPr>
+        </p:nvSpPr>
+        <p:spPr/>
+        <p:txBody>
+          <a:bodyPr/>
+          <a:lstStyle/>
+          <a:p/>
+          <a:p>
+            <a:pPr>
+              <a:defRPr sz="1800">
+                <a:solidFill>
+                  <a:srgbClr val="000000"/>
+                </a:solidFill>
+                <a:latin typeface="Times New Roman"/>
+              </a:defRPr>
+            </a:pPr>
+            <a:r>
+              <a:t>The code is clean, well-documented, and follows best practices in both Python and Java programming.</a:t>
+            </a:r>
+          </a:p>
+          <a:p>
+            <a:pPr>
+              <a:defRPr sz="1800">
+                <a:solidFill>
+                  <a:srgbClr val="000000"/>
+                </a:solidFill>
+                <a:latin typeface="Times New Roman"/>
+              </a:defRPr>
+            </a:pPr>
+            <a:r>
+              <a:t>The repository includes unit tests for many of the solutions, ensuring the correctness and reliability of the code.</a:t>
+            </a:r>
+          </a:p>
+        </p:txBody>
+      </p:sp>
+      <p:sp>
+        <p:nvSpPr>
+          <p:cNvPr id="4" name="TextBox 3"/>
+          <p:cNvSpPr txBox="1"/>
+          <p:nvPr/>
+        </p:nvSpPr>
+        <p:spPr>
+          <a:xfrm>
+            <a:off x="7772400" y="6400800"/>
+            <a:ext cx="914400" cy="457200"/>
+          </a:xfrm>
+          <a:prstGeom prst="rect">
+            <a:avLst/>
+          </a:prstGeom>
+          <a:noFill/>
+        </p:spPr>
+        <p:txBody>
+          <a:bodyPr wrap="none">
+            <a:spAutoFit/>
+          </a:bodyPr>
+          <a:lstStyle/>
+          <a:p>
+            <a:pPr>
+              <a:defRPr sz="1200">
+                <a:solidFill>
+                  <a:srgbClr val="646464"/>
+                </a:solidFill>
+                <a:latin typeface="Times New Roman"/>
+              </a:defRPr>
+            </a:pPr>
+            <a:r>
+              <a:t>6</a:t>
+            </a:r>
+          </a:p>
+        </p:txBody>
+      </p:sp>
+    </p:spTree>
+  </p:cSld>
+  <p:clrMapOvr>
+    <a:masterClrMapping/>
+  </p:clrMapOvr>
+</p:sld>
+</file>
+
+<file path=ppt/slides/slide7.xml><?xml version="1.0" encoding="utf-8"?>
+<p:sld xmlns:a="http://schemas.openxmlformats.org/drawingml/2006/main" xmlns:p="http://schemas.openxmlformats.org/presentationml/2006/main" xmlns:r="http://schemas.openxmlformats.org/officeDocument/2006/relationships">
+  <p:cSld>
+    <p:spTree>
+      <p:nvGrpSpPr>
+        <p:cNvPr id="1" name=""/>
+        <p:cNvGrpSpPr/>
+        <p:nvPr/>
+      </p:nvGrpSpPr>
+      <p:grpSpPr/>
+      <p:sp>
+        <p:nvSpPr>
+          <p:cNvPr id="2" name="Title 1"/>
+          <p:cNvSpPr>
+            <a:spLocks noGrp="1"/>
+          </p:cNvSpPr>
+          <p:nvPr>
+            <p:ph type="title"/>
+          </p:nvPr>
+        </p:nvSpPr>
+        <p:spPr/>
+        <p:txBody>
+          <a:bodyPr/>
+          <a:lstStyle/>
+          <a:p>
+            <a:r>
+              <a:rPr>
+                <a:solidFill>
+                  <a:srgbClr val="000000"/>
+                </a:solidFill>
+                <a:latin typeface="Times New Roman"/>
+              </a:rPr>
+              <a:t>Community and Contribution</a:t>
+            </a:r>
+          </a:p>
+        </p:txBody>
+      </p:sp>
+      <p:sp>
+        <p:nvSpPr>
+          <p:cNvPr id="3" name="Content Placeholder 2"/>
+          <p:cNvSpPr>
+            <a:spLocks noGrp="1"/>
+          </p:cNvSpPr>
+          <p:nvPr>
+            <p:ph idx="1"/>
+          </p:nvPr>
+        </p:nvSpPr>
+        <p:spPr/>
+        <p:txBody>
+          <a:bodyPr/>
+          <a:lstStyle/>
+          <a:p/>
+          <a:p>
+            <a:pPr>
+              <a:defRPr sz="1800">
+                <a:solidFill>
+                  <a:srgbClr val="000000"/>
+                </a:solidFill>
+                <a:latin typeface="Times New Roman"/>
+              </a:defRPr>
+            </a:pPr>
+            <a:r>
+              <a:t>The repository welcomes contributions from the community, allowing other developers to submit their own solutions and improvements.</a:t>
+            </a:r>
+          </a:p>
+          <a:p>
+            <a:pPr>
+              <a:defRPr sz="1800">
+                <a:solidFill>
+                  <a:srgbClr val="000000"/>
+                </a:solidFill>
+                <a:latin typeface="Times New Roman"/>
+              </a:defRPr>
+            </a:pPr>
+            <a:r>
+              <a:t>A README file provides guidelines for contributing and issues can be tracked via the GitHub Issues page.</a:t>
+            </a:r>
+          </a:p>
+        </p:txBody>
+      </p:sp>
+      <p:sp>
+        <p:nvSpPr>
+          <p:cNvPr id="4" name="TextBox 3"/>
+          <p:cNvSpPr txBox="1"/>
+          <p:nvPr/>
+        </p:nvSpPr>
+        <p:spPr>
+          <a:xfrm>
+            <a:off x="7772400" y="6400800"/>
+            <a:ext cx="914400" cy="457200"/>
+          </a:xfrm>
+          <a:prstGeom prst="rect">
+            <a:avLst/>
+          </a:prstGeom>
+          <a:noFill/>
+        </p:spPr>
+        <p:txBody>
+          <a:bodyPr wrap="none">
+            <a:spAutoFit/>
+          </a:bodyPr>
+          <a:lstStyle/>
+          <a:p>
+            <a:pPr>
+              <a:defRPr sz="1200">
+                <a:solidFill>
+                  <a:srgbClr val="646464"/>
+                </a:solidFill>
+                <a:latin typeface="Times New Roman"/>
+              </a:defRPr>
+            </a:pPr>
+            <a:r>
+              <a:t>7</a:t>
+            </a:r>
+          </a:p>
+        </p:txBody>
+      </p:sp>
+    </p:spTree>
+  </p:cSld>
+  <p:clrMapOvr>
+    <a:masterClrMapping/>
+  </p:clrMapOvr>
+</p:sld>
+</file>
+
+<file path=ppt/slides/slide8.xml><?xml version="1.0" encoding="utf-8"?>
+<p:sld xmlns:a="http://schemas.openxmlformats.org/drawingml/2006/main" xmlns:p="http://schemas.openxmlformats.org/presentationml/2006/main" xmlns:r="http://schemas.openxmlformats.org/officeDocument/2006/relationships">
+  <p:cSld>
+    <p:spTree>
+      <p:nvGrpSpPr>
+        <p:cNvPr id="1" name=""/>
+        <p:cNvGrpSpPr/>
+        <p:nvPr/>
+      </p:nvGrpSpPr>
+      <p:grpSpPr/>
+      <p:sp>
+        <p:nvSpPr>
+          <p:cNvPr id="2" name="Title 1"/>
+          <p:cNvSpPr>
+            <a:spLocks noGrp="1"/>
+          </p:cNvSpPr>
+          <p:nvPr>
+            <p:ph type="title"/>
+          </p:nvPr>
+        </p:nvSpPr>
+        <p:spPr/>
+        <p:txBody>
+          <a:bodyPr/>
+          <a:lstStyle/>
+          <a:p>
+            <a:r>
+              <a:rPr>
+                <a:solidFill>
+                  <a:srgbClr val="000000"/>
+                </a:solidFill>
+                <a:latin typeface="Times New Roman"/>
+              </a:rPr>
+              <a:t>Patent-style Claims</a:t>
+            </a:r>
+          </a:p>
+        </p:txBody>
+      </p:sp>
+      <p:sp>
+        <p:nvSpPr>
+          <p:cNvPr id="3" name="Content Placeholder 2"/>
+          <p:cNvSpPr>
+            <a:spLocks noGrp="1"/>
+          </p:cNvSpPr>
+          <p:nvPr>
+            <p:ph idx="1"/>
+          </p:nvPr>
+        </p:nvSpPr>
+        <p:spPr/>
+        <p:txBody>
+          <a:bodyPr/>
+          <a:lstStyle/>
+          <a:p/>
+          <a:p>
+            <a:pPr>
+              <a:defRPr sz="1600">
+                <a:solidFill>
+                  <a:srgbClr val="000000"/>
+                </a:solidFill>
+                <a:latin typeface="Times New Roman"/>
+              </a:defRPr>
+            </a:pPr>
+            <a:r>
+              <a:t>A comprehensive repository of coding challenges and solutions for enhancing algorithmic and data structure skills.</a:t>
+            </a:r>
+          </a:p>
+          <a:p>
+            <a:pPr>
+              <a:defRPr sz="1600">
+                <a:solidFill>
+                  <a:srgbClr val="000000"/>
+                </a:solidFill>
+                <a:latin typeface="Times New Roman"/>
+              </a:defRPr>
+            </a:pPr>
+            <a:r>
+              <a:t>Solutions provided in both Python and Java, catering to a wide range of developers.</a:t>
+            </a:r>
+          </a:p>
+        </p:txBody>
+      </p:sp>
+      <p:sp>
+        <p:nvSpPr>
+          <p:cNvPr id="4" name="TextBox 3"/>
+          <p:cNvSpPr txBox="1"/>
+          <p:nvPr/>
+        </p:nvSpPr>
+        <p:spPr>
+          <a:xfrm>
+            <a:off x="7772400" y="6400800"/>
+            <a:ext cx="914400" cy="457200"/>
+          </a:xfrm>
+          <a:prstGeom prst="rect">
+            <a:avLst/>
+          </a:prstGeom>
+          <a:noFill/>
+        </p:spPr>
+        <p:txBody>
+          <a:bodyPr wrap="none">
+            <a:spAutoFit/>
+          </a:bodyPr>
+          <a:lstStyle/>
+          <a:p>
+            <a:pPr>
+              <a:defRPr sz="1200">
+                <a:solidFill>
+                  <a:srgbClr val="646464"/>
+                </a:solidFill>
+                <a:latin typeface="Times New Roman"/>
+              </a:defRPr>
+            </a:pPr>
+            <a:r>
+              <a:t>8</a:t>
             </a:r>
           </a:p>
         </p:txBody>

</xml_diff>

<commit_message>
docs: Add enthusiastic README and project files
</commit_message>
<xml_diff>
--- a/backend/generated_files/slides.pptx
+++ b/backend/generated_files/slides.pptx
@@ -10,9 +10,6 @@
     <p:sldId id="258" r:id="rId9"/>
     <p:sldId id="259" r:id="rId10"/>
     <p:sldId id="260" r:id="rId11"/>
-    <p:sldId id="261" r:id="rId12"/>
-    <p:sldId id="262" r:id="rId13"/>
-    <p:sldId id="263" r:id="rId14"/>
   </p:sldIdLst>
   <p:sldSz cx="9144000" cy="6858000" type="screen4x3"/>
   <p:notesSz cx="6858000" cy="9144000"/>
@@ -3117,7 +3114,7 @@
                 </a:solidFill>
                 <a:latin typeface="Times New Roman"/>
               </a:rPr>
-              <a:t>Technical Assessment Report: code_crush</a:t>
+              <a:t>Certificate of Achievement</a:t>
             </a:r>
           </a:p>
         </p:txBody>
@@ -3144,7 +3141,7 @@
                 </a:solidFill>
                 <a:latin typeface="Times New Roman"/>
               </a:rPr>
-              <a:t>The GitHub repository 'code_crush' hosted by user Midhun-M-git contains a comprehensive collection of coding challenges and solutions, with a focus on algorithmic problem-solving and data structures. The project is organized into multiple directories, each representing a different category of coding problems, such as arrays, strings, linked lists, trees, and graphs. Solutions are provided in both Python and Java, demonstrating the versatility and applicability of the code across different programming languages. The repository includes detailed explanations for each solution, enhancing its educational value. Overall, code_crush serves as an excellent resource for developers and students looking to improve their coding skills through practical examples and well-documented solutions. (Analyzed GitHub Repo: https://github.com/Midhun-M-git/code_crush)</a:t>
+              <a:t>This certificate is awarded to recognize outstanding contributions and accomplishments in the field of technology and innovation. It serves as a formal acknowledgment of dedication, expertise, and excellence demonstrated in a specific project or endeavor.</a:t>
             </a:r>
           </a:p>
         </p:txBody>
@@ -3189,7 +3186,7 @@
                 </a:solidFill>
                 <a:latin typeface="Times New Roman"/>
               </a:rPr>
-              <a:t>Introduction</a:t>
+              <a:t>Purpose of the Certificate</a:t>
             </a:r>
           </a:p>
         </p:txBody>
@@ -3219,7 +3216,7 @@
               </a:defRPr>
             </a:pPr>
             <a:r>
-              <a:t>The code_crush repository is a curated collection of coding challenges and their corresponding solutions, designed to help developers and students enhance their algorithmic and data structure skills.</a:t>
+              <a:t>To formally recognize and validate the recipient's achievements in a specific domain.</a:t>
             </a:r>
           </a:p>
           <a:p>
@@ -3232,7 +3229,7 @@
               </a:defRPr>
             </a:pPr>
             <a:r>
-              <a:t>The repository is hosted on GitHub and managed by the user Midhun-M-git.</a:t>
+              <a:t>To serve as a professional credential that can be included in portfolios, resumes, or academic applications.</a:t>
             </a:r>
           </a:p>
         </p:txBody>
@@ -3313,7 +3310,7 @@
                 </a:solidFill>
                 <a:latin typeface="Times New Roman"/>
               </a:rPr>
-              <a:t>Project Structure</a:t>
+              <a:t>Key Features</a:t>
             </a:r>
           </a:p>
         </p:txBody>
@@ -3343,7 +3340,7 @@
               </a:defRPr>
             </a:pPr>
             <a:r>
-              <a:t>The project is organized into multiple directories, each representing a different category of coding problems, such as arrays, strings, linked lists, trees, and graphs.</a:t>
+              <a:t>Includes the recipient's name, the awarding organization, and the date of issuance.</a:t>
             </a:r>
           </a:p>
           <a:p>
@@ -3356,7 +3353,7 @@
               </a:defRPr>
             </a:pPr>
             <a:r>
-              <a:t>Each directory contains a series of problem files, with solutions provided in both Python and Java.</a:t>
+              <a:t>Features an official seal or signature to authenticate the document.</a:t>
             </a:r>
           </a:p>
         </p:txBody>
@@ -3437,7 +3434,7 @@
                 </a:solidFill>
                 <a:latin typeface="Times New Roman"/>
               </a:rPr>
-              <a:t>Content Overview</a:t>
+              <a:t>Applications</a:t>
             </a:r>
           </a:p>
         </p:txBody>
@@ -3467,7 +3464,7 @@
               </a:defRPr>
             </a:pPr>
             <a:r>
-              <a:t>The repository includes a wide range of coding challenges, covering fundamental data structures and advanced algorithmic concepts.</a:t>
+              <a:t>Used in academic and professional settings to demonstrate expertise and accomplishments.</a:t>
             </a:r>
           </a:p>
           <a:p>
@@ -3480,7 +3477,7 @@
               </a:defRPr>
             </a:pPr>
             <a:r>
-              <a:t>Solutions are provided in both Python and Java, catering to developers familiar with these programming languages.</a:t>
+              <a:t>Often required for career advancement, job applications, or further education.</a:t>
             </a:r>
           </a:p>
         </p:txBody>
@@ -3561,7 +3558,7 @@
                 </a:solidFill>
                 <a:latin typeface="Times New Roman"/>
               </a:rPr>
-              <a:t>Educational Value</a:t>
+              <a:t>Patent-style Claims</a:t>
             </a:r>
           </a:p>
         </p:txBody>
@@ -3583,7 +3580,7 @@
           <a:p/>
           <a:p>
             <a:pPr>
-              <a:defRPr sz="1800">
+              <a:defRPr sz="1600">
                 <a:solidFill>
                   <a:srgbClr val="000000"/>
                 </a:solidFill>
@@ -3591,12 +3588,12 @@
               </a:defRPr>
             </a:pPr>
             <a:r>
-              <a:t>Each solution is accompanied by detailed explanations, making the repository an excellent learning tool for developers and students.</a:t>
+              <a:t>A certificate of achievement for recognizing outstanding contributions in a specific field.</a:t>
             </a:r>
           </a:p>
           <a:p>
             <a:pPr>
-              <a:defRPr sz="1800">
+              <a:defRPr sz="1600">
                 <a:solidFill>
                   <a:srgbClr val="000000"/>
                 </a:solidFill>
@@ -3604,7 +3601,20 @@
               </a:defRPr>
             </a:pPr>
             <a:r>
-              <a:t>The variety of problems and solutions helps users to practice and reinforce their understanding of coding concepts.</a:t>
+              <a:t>A document featuring an official seal and signature to authenticate professional accomplishments.</a:t>
+            </a:r>
+          </a:p>
+          <a:p>
+            <a:pPr>
+              <a:defRPr sz="1600">
+                <a:solidFill>
+                  <a:srgbClr val="000000"/>
+                </a:solidFill>
+                <a:latin typeface="Times New Roman"/>
+              </a:defRPr>
+            </a:pPr>
+            <a:r>
+              <a:t>A credential used for academic and career advancement purposes.</a:t>
             </a:r>
           </a:p>
         </p:txBody>
@@ -3641,378 +3651,6 @@
             </a:pPr>
             <a:r>
               <a:t>5</a:t>
-            </a:r>
-          </a:p>
-        </p:txBody>
-      </p:sp>
-    </p:spTree>
-  </p:cSld>
-  <p:clrMapOvr>
-    <a:masterClrMapping/>
-  </p:clrMapOvr>
-</p:sld>
-</file>
-
-<file path=ppt/slides/slide6.xml><?xml version="1.0" encoding="utf-8"?>
-<p:sld xmlns:a="http://schemas.openxmlformats.org/drawingml/2006/main" xmlns:p="http://schemas.openxmlformats.org/presentationml/2006/main" xmlns:r="http://schemas.openxmlformats.org/officeDocument/2006/relationships">
-  <p:cSld>
-    <p:spTree>
-      <p:nvGrpSpPr>
-        <p:cNvPr id="1" name=""/>
-        <p:cNvGrpSpPr/>
-        <p:nvPr/>
-      </p:nvGrpSpPr>
-      <p:grpSpPr/>
-      <p:sp>
-        <p:nvSpPr>
-          <p:cNvPr id="2" name="Title 1"/>
-          <p:cNvSpPr>
-            <a:spLocks noGrp="1"/>
-          </p:cNvSpPr>
-          <p:nvPr>
-            <p:ph type="title"/>
-          </p:nvPr>
-        </p:nvSpPr>
-        <p:spPr/>
-        <p:txBody>
-          <a:bodyPr/>
-          <a:lstStyle/>
-          <a:p>
-            <a:r>
-              <a:rPr>
-                <a:solidFill>
-                  <a:srgbClr val="000000"/>
-                </a:solidFill>
-                <a:latin typeface="Times New Roman"/>
-              </a:rPr>
-              <a:t>Technical Excellence</a:t>
-            </a:r>
-          </a:p>
-        </p:txBody>
-      </p:sp>
-      <p:sp>
-        <p:nvSpPr>
-          <p:cNvPr id="3" name="Content Placeholder 2"/>
-          <p:cNvSpPr>
-            <a:spLocks noGrp="1"/>
-          </p:cNvSpPr>
-          <p:nvPr>
-            <p:ph idx="1"/>
-          </p:nvPr>
-        </p:nvSpPr>
-        <p:spPr/>
-        <p:txBody>
-          <a:bodyPr/>
-          <a:lstStyle/>
-          <a:p/>
-          <a:p>
-            <a:pPr>
-              <a:defRPr sz="1800">
-                <a:solidFill>
-                  <a:srgbClr val="000000"/>
-                </a:solidFill>
-                <a:latin typeface="Times New Roman"/>
-              </a:defRPr>
-            </a:pPr>
-            <a:r>
-              <a:t>The code is clean, well-documented, and follows best practices in both Python and Java programming.</a:t>
-            </a:r>
-          </a:p>
-          <a:p>
-            <a:pPr>
-              <a:defRPr sz="1800">
-                <a:solidFill>
-                  <a:srgbClr val="000000"/>
-                </a:solidFill>
-                <a:latin typeface="Times New Roman"/>
-              </a:defRPr>
-            </a:pPr>
-            <a:r>
-              <a:t>The repository includes unit tests for many of the solutions, ensuring the correctness and reliability of the code.</a:t>
-            </a:r>
-          </a:p>
-        </p:txBody>
-      </p:sp>
-      <p:sp>
-        <p:nvSpPr>
-          <p:cNvPr id="4" name="TextBox 3"/>
-          <p:cNvSpPr txBox="1"/>
-          <p:nvPr/>
-        </p:nvSpPr>
-        <p:spPr>
-          <a:xfrm>
-            <a:off x="7772400" y="6400800"/>
-            <a:ext cx="914400" cy="457200"/>
-          </a:xfrm>
-          <a:prstGeom prst="rect">
-            <a:avLst/>
-          </a:prstGeom>
-          <a:noFill/>
-        </p:spPr>
-        <p:txBody>
-          <a:bodyPr wrap="none">
-            <a:spAutoFit/>
-          </a:bodyPr>
-          <a:lstStyle/>
-          <a:p>
-            <a:pPr>
-              <a:defRPr sz="1200">
-                <a:solidFill>
-                  <a:srgbClr val="646464"/>
-                </a:solidFill>
-                <a:latin typeface="Times New Roman"/>
-              </a:defRPr>
-            </a:pPr>
-            <a:r>
-              <a:t>6</a:t>
-            </a:r>
-          </a:p>
-        </p:txBody>
-      </p:sp>
-    </p:spTree>
-  </p:cSld>
-  <p:clrMapOvr>
-    <a:masterClrMapping/>
-  </p:clrMapOvr>
-</p:sld>
-</file>
-
-<file path=ppt/slides/slide7.xml><?xml version="1.0" encoding="utf-8"?>
-<p:sld xmlns:a="http://schemas.openxmlformats.org/drawingml/2006/main" xmlns:p="http://schemas.openxmlformats.org/presentationml/2006/main" xmlns:r="http://schemas.openxmlformats.org/officeDocument/2006/relationships">
-  <p:cSld>
-    <p:spTree>
-      <p:nvGrpSpPr>
-        <p:cNvPr id="1" name=""/>
-        <p:cNvGrpSpPr/>
-        <p:nvPr/>
-      </p:nvGrpSpPr>
-      <p:grpSpPr/>
-      <p:sp>
-        <p:nvSpPr>
-          <p:cNvPr id="2" name="Title 1"/>
-          <p:cNvSpPr>
-            <a:spLocks noGrp="1"/>
-          </p:cNvSpPr>
-          <p:nvPr>
-            <p:ph type="title"/>
-          </p:nvPr>
-        </p:nvSpPr>
-        <p:spPr/>
-        <p:txBody>
-          <a:bodyPr/>
-          <a:lstStyle/>
-          <a:p>
-            <a:r>
-              <a:rPr>
-                <a:solidFill>
-                  <a:srgbClr val="000000"/>
-                </a:solidFill>
-                <a:latin typeface="Times New Roman"/>
-              </a:rPr>
-              <a:t>Community and Contribution</a:t>
-            </a:r>
-          </a:p>
-        </p:txBody>
-      </p:sp>
-      <p:sp>
-        <p:nvSpPr>
-          <p:cNvPr id="3" name="Content Placeholder 2"/>
-          <p:cNvSpPr>
-            <a:spLocks noGrp="1"/>
-          </p:cNvSpPr>
-          <p:nvPr>
-            <p:ph idx="1"/>
-          </p:nvPr>
-        </p:nvSpPr>
-        <p:spPr/>
-        <p:txBody>
-          <a:bodyPr/>
-          <a:lstStyle/>
-          <a:p/>
-          <a:p>
-            <a:pPr>
-              <a:defRPr sz="1800">
-                <a:solidFill>
-                  <a:srgbClr val="000000"/>
-                </a:solidFill>
-                <a:latin typeface="Times New Roman"/>
-              </a:defRPr>
-            </a:pPr>
-            <a:r>
-              <a:t>The repository welcomes contributions from the community, allowing other developers to submit their own solutions and improvements.</a:t>
-            </a:r>
-          </a:p>
-          <a:p>
-            <a:pPr>
-              <a:defRPr sz="1800">
-                <a:solidFill>
-                  <a:srgbClr val="000000"/>
-                </a:solidFill>
-                <a:latin typeface="Times New Roman"/>
-              </a:defRPr>
-            </a:pPr>
-            <a:r>
-              <a:t>A README file provides guidelines for contributing and issues can be tracked via the GitHub Issues page.</a:t>
-            </a:r>
-          </a:p>
-        </p:txBody>
-      </p:sp>
-      <p:sp>
-        <p:nvSpPr>
-          <p:cNvPr id="4" name="TextBox 3"/>
-          <p:cNvSpPr txBox="1"/>
-          <p:nvPr/>
-        </p:nvSpPr>
-        <p:spPr>
-          <a:xfrm>
-            <a:off x="7772400" y="6400800"/>
-            <a:ext cx="914400" cy="457200"/>
-          </a:xfrm>
-          <a:prstGeom prst="rect">
-            <a:avLst/>
-          </a:prstGeom>
-          <a:noFill/>
-        </p:spPr>
-        <p:txBody>
-          <a:bodyPr wrap="none">
-            <a:spAutoFit/>
-          </a:bodyPr>
-          <a:lstStyle/>
-          <a:p>
-            <a:pPr>
-              <a:defRPr sz="1200">
-                <a:solidFill>
-                  <a:srgbClr val="646464"/>
-                </a:solidFill>
-                <a:latin typeface="Times New Roman"/>
-              </a:defRPr>
-            </a:pPr>
-            <a:r>
-              <a:t>7</a:t>
-            </a:r>
-          </a:p>
-        </p:txBody>
-      </p:sp>
-    </p:spTree>
-  </p:cSld>
-  <p:clrMapOvr>
-    <a:masterClrMapping/>
-  </p:clrMapOvr>
-</p:sld>
-</file>
-
-<file path=ppt/slides/slide8.xml><?xml version="1.0" encoding="utf-8"?>
-<p:sld xmlns:a="http://schemas.openxmlformats.org/drawingml/2006/main" xmlns:p="http://schemas.openxmlformats.org/presentationml/2006/main" xmlns:r="http://schemas.openxmlformats.org/officeDocument/2006/relationships">
-  <p:cSld>
-    <p:spTree>
-      <p:nvGrpSpPr>
-        <p:cNvPr id="1" name=""/>
-        <p:cNvGrpSpPr/>
-        <p:nvPr/>
-      </p:nvGrpSpPr>
-      <p:grpSpPr/>
-      <p:sp>
-        <p:nvSpPr>
-          <p:cNvPr id="2" name="Title 1"/>
-          <p:cNvSpPr>
-            <a:spLocks noGrp="1"/>
-          </p:cNvSpPr>
-          <p:nvPr>
-            <p:ph type="title"/>
-          </p:nvPr>
-        </p:nvSpPr>
-        <p:spPr/>
-        <p:txBody>
-          <a:bodyPr/>
-          <a:lstStyle/>
-          <a:p>
-            <a:r>
-              <a:rPr>
-                <a:solidFill>
-                  <a:srgbClr val="000000"/>
-                </a:solidFill>
-                <a:latin typeface="Times New Roman"/>
-              </a:rPr>
-              <a:t>Patent-style Claims</a:t>
-            </a:r>
-          </a:p>
-        </p:txBody>
-      </p:sp>
-      <p:sp>
-        <p:nvSpPr>
-          <p:cNvPr id="3" name="Content Placeholder 2"/>
-          <p:cNvSpPr>
-            <a:spLocks noGrp="1"/>
-          </p:cNvSpPr>
-          <p:nvPr>
-            <p:ph idx="1"/>
-          </p:nvPr>
-        </p:nvSpPr>
-        <p:spPr/>
-        <p:txBody>
-          <a:bodyPr/>
-          <a:lstStyle/>
-          <a:p/>
-          <a:p>
-            <a:pPr>
-              <a:defRPr sz="1600">
-                <a:solidFill>
-                  <a:srgbClr val="000000"/>
-                </a:solidFill>
-                <a:latin typeface="Times New Roman"/>
-              </a:defRPr>
-            </a:pPr>
-            <a:r>
-              <a:t>A comprehensive repository of coding challenges and solutions for enhancing algorithmic and data structure skills.</a:t>
-            </a:r>
-          </a:p>
-          <a:p>
-            <a:pPr>
-              <a:defRPr sz="1600">
-                <a:solidFill>
-                  <a:srgbClr val="000000"/>
-                </a:solidFill>
-                <a:latin typeface="Times New Roman"/>
-              </a:defRPr>
-            </a:pPr>
-            <a:r>
-              <a:t>Solutions provided in both Python and Java, catering to a wide range of developers.</a:t>
-            </a:r>
-          </a:p>
-        </p:txBody>
-      </p:sp>
-      <p:sp>
-        <p:nvSpPr>
-          <p:cNvPr id="4" name="TextBox 3"/>
-          <p:cNvSpPr txBox="1"/>
-          <p:nvPr/>
-        </p:nvSpPr>
-        <p:spPr>
-          <a:xfrm>
-            <a:off x="7772400" y="6400800"/>
-            <a:ext cx="914400" cy="457200"/>
-          </a:xfrm>
-          <a:prstGeom prst="rect">
-            <a:avLst/>
-          </a:prstGeom>
-          <a:noFill/>
-        </p:spPr>
-        <p:txBody>
-          <a:bodyPr wrap="none">
-            <a:spAutoFit/>
-          </a:bodyPr>
-          <a:lstStyle/>
-          <a:p>
-            <a:pPr>
-              <a:defRPr sz="1200">
-                <a:solidFill>
-                  <a:srgbClr val="646464"/>
-                </a:solidFill>
-                <a:latin typeface="Times New Roman"/>
-              </a:defRPr>
-            </a:pPr>
-            <a:r>
-              <a:t>8</a:t>
             </a:r>
           </a:p>
         </p:txBody>

</xml_diff>